<commit_message>
Deck: lámina de tres maniobras y textos al presupuesto
- fig_3_9_3_10_3_11: escultor, trofismo y tono en una sola lámina.
- Tarjetas y fichas ampliadas hasta ~90% del límite de caracteres.
- Referencias repartidas por figura y página.

Co-authored-by: arena-agent <297053741+arena-agent@users.noreply.github.com>
</commit_message>
<xml_diff>
--- a/decks/semiotecnia-torax/semiotecnia_del_torax.pptx
+++ b/decks/semiotecnia-torax/semiotecnia_del_torax.pptx
@@ -4160,7 +4160,7 @@
                 </a:solidFill>
                 <a:latin typeface="Montserrat"/>
               </a:rPr>
-              <a:t>Acentúa la curvatura dorsal en su tercio medio; el dorso se redondea sin desviación lateral de las apófisis espinosas.</a:t>
+              <a:t>Acentúa la curvatura dorsal en su tercio medio: el dorso se redondea sin desviación lateral de las apófisis espinosas.</a:t>
             </a:r>
           </a:p>
         </p:txBody>
@@ -4319,7 +4319,7 @@
                 </a:solidFill>
                 <a:latin typeface="Montserrat"/>
               </a:rPr>
-              <a:t>Exagera la curvatura en el segmento inferior de la columna dorsal, por debajo del tercio medio.</a:t>
+              <a:t>Exagera la curvatura en el segmento inferior de la columna dorsal, por debajo del tercio medio, sin lateralizar la línea de apófisis espinosas.</a:t>
             </a:r>
           </a:p>
         </p:txBody>
@@ -4974,7 +4974,7 @@
                 </a:solidFill>
                 <a:latin typeface="Montserrat"/>
               </a:rPr>
-              <a:t>Hipertrofia y engrosamiento rítmico inspiratorio del esternocleidomastoideo, con depresión de las fosas supraclaviculares.</a:t>
+              <a:t>Hipertrofia y engrosamiento rítmico inspiratorio del esternocleidomastoideo, con depresión de las fosas supraclaviculares en cada inspiración.</a:t>
             </a:r>
           </a:p>
         </p:txBody>
@@ -5292,7 +5292,7 @@
                 </a:solidFill>
                 <a:latin typeface="Montserrat"/>
               </a:rPr>
-              <a:t>Dedos hipocráticos: acropaquia con redondeo del extremo digital e incurvación de la uña.</a:t>
+              <a:t>Dedos hipocráticos: acropaquia con redondeo del extremo digital, incurvación de la uña y aumento del ángulo que forma con el lecho.</a:t>
             </a:r>
           </a:p>
         </p:txBody>
@@ -6047,7 +6047,7 @@
                 </a:solidFill>
                 <a:latin typeface="Montserrat"/>
               </a:rPr>
-              <a:t>Deslizamiento palmar plano sobre caras anterior, posterior y laterales; censa relieve cutáneo, deformaciones óseas y tumefacciones.</a:t>
+              <a:t>Deslizamiento palmar plano sobre las caras anterior, posterior y laterales: censa relieve cutáneo, deformaciones óseas y tumefacciones.</a:t>
             </a:r>
           </a:p>
         </p:txBody>
@@ -6252,7 +6252,7 @@
                 </a:solidFill>
                 <a:latin typeface="Montserrat"/>
               </a:rPr>
-              <a:t>Pinzamiento bimanual de piel y tejido subcutáneo; compresión con la punta del índice sobre las masas musculares.</a:t>
+              <a:t>Pinzamiento bimanual de piel y tejido subcutáneo en zonas simétricas, y compresión con la punta del índice sobre las masas musculares.</a:t>
             </a:r>
           </a:p>
         </p:txBody>
@@ -6457,7 +6457,7 @@
                 </a:solidFill>
                 <a:latin typeface="Montserrat"/>
               </a:rPr>
-              <a:t>Supraclavicular desde atrás, con tres dedos y hombros elevados; axilar en sus cinco grupos, uno por uno.</a:t>
+              <a:t>Supraclavicular desde atrás, con tres dedos y los hombros elevados; axilar en sus cinco grupos, uno por uno y con el brazo sostenido.</a:t>
             </a:r>
           </a:p>
         </p:txBody>
@@ -6662,7 +6662,7 @@
                 </a:solidFill>
                 <a:latin typeface="Montserrat"/>
               </a:rPr>
-              <a:t>Compresión convergente bimanual sobre puntos homotópicos, a igual nivel por delante y por detrás.</a:t>
+              <a:t>Compresión convergente bimanual sobre puntos homotópicos anteriores y posteriores, a igual nivel: el cese elástico normal es simétrico.</a:t>
             </a:r>
           </a:p>
         </p:txBody>
@@ -6867,7 +6867,7 @@
                 </a:solidFill>
                 <a:latin typeface="Montserrat"/>
               </a:rPr>
-              <a:t>Ruault en los vértices, bases anteriores y posteriores; después vibraciones vocales con «treinta y tres».</a:t>
+              <a:t>Ruault en los vértices, luego bases anteriores y posteriores; al final, vibraciones vocales con «treinta y tres» hasta su desaparición.</a:t>
             </a:r>
           </a:p>
         </p:txBody>
@@ -6927,7 +6927,7 @@
                 </a:solidFill>
                 <a:latin typeface="Montserrat"/>
               </a:rPr>
-              <a:t>PALPACIÓN · MANIOBRA 1</a:t>
+              <a:t>PALPACIÓN · MANIOBRAS 1 Y 2</a:t>
             </a:r>
           </a:p>
         </p:txBody>
@@ -6969,7 +6969,7 @@
                 </a:solidFill>
                 <a:latin typeface="Montserrat"/>
               </a:rPr>
-              <a:t>La pared que la mano registra</a:t>
+              <a:t>Escultor, trofismo y tono</a:t>
             </a:r>
           </a:p>
         </p:txBody>
@@ -7154,638 +7154,8 @@
         </p:nvSpPr>
         <p:spPr>
           <a:xfrm>
-            <a:off x="594360" y="1417320"/>
-            <a:ext cx="6949440" cy="1325880"/>
-          </a:xfrm>
-          <a:prstGeom prst="roundRect">
-            <a:avLst>
-              <a:gd name="adj" fmla="val 4000"/>
-            </a:avLst>
-          </a:prstGeom>
-          <a:solidFill>
-            <a:srgbClr val="FFFFFF"/>
-          </a:solidFill>
-          <a:ln w="7620">
-            <a:solidFill>
-              <a:srgbClr val="D9DDF2"/>
-            </a:solidFill>
-          </a:ln>
-          <a:effectLst/>
-        </p:spPr>
-        <p:style>
-          <a:lnRef idx="1">
-            <a:schemeClr val="accent1"/>
-          </a:lnRef>
-          <a:fillRef idx="3">
-            <a:schemeClr val="accent1"/>
-          </a:fillRef>
-          <a:effectRef idx="2">
-            <a:schemeClr val="accent1"/>
-          </a:effectRef>
-          <a:fontRef idx="minor">
-            <a:schemeClr val="lt1"/>
-          </a:fontRef>
-        </p:style>
-        <p:txBody>
-          <a:bodyPr rtlCol="0" anchor="ctr"/>
-          <a:lstStyle/>
-          <a:p>
-            <a:pPr algn="ctr"/>
-          </a:p>
-        </p:txBody>
-      </p:sp>
-      <p:sp>
-        <p:nvSpPr>
-          <p:cNvPr id="9" name="Rectangle 8"/>
-          <p:cNvSpPr/>
-          <p:nvPr/>
-        </p:nvSpPr>
-        <p:spPr>
-          <a:xfrm>
-            <a:off x="594360" y="1417320"/>
-            <a:ext cx="82296" cy="1325880"/>
-          </a:xfrm>
-          <a:prstGeom prst="rect">
-            <a:avLst/>
-          </a:prstGeom>
-          <a:solidFill>
-            <a:srgbClr val="3854CC"/>
-          </a:solidFill>
-          <a:ln>
-            <a:noFill/>
-          </a:ln>
-          <a:effectLst/>
-        </p:spPr>
-        <p:style>
-          <a:lnRef idx="1">
-            <a:schemeClr val="accent1"/>
-          </a:lnRef>
-          <a:fillRef idx="3">
-            <a:schemeClr val="accent1"/>
-          </a:fillRef>
-          <a:effectRef idx="2">
-            <a:schemeClr val="accent1"/>
-          </a:effectRef>
-          <a:fontRef idx="minor">
-            <a:schemeClr val="lt1"/>
-          </a:fontRef>
-        </p:style>
-        <p:txBody>
-          <a:bodyPr rtlCol="0" anchor="ctr"/>
-          <a:lstStyle/>
-          <a:p>
-            <a:pPr algn="ctr"/>
-          </a:p>
-        </p:txBody>
-      </p:sp>
-      <p:sp>
-        <p:nvSpPr>
-          <p:cNvPr id="10" name="Rounded Rectangle 9"/>
-          <p:cNvSpPr/>
-          <p:nvPr/>
-        </p:nvSpPr>
-        <p:spPr>
-          <a:xfrm>
-            <a:off x="868680" y="1536192"/>
-            <a:ext cx="1463040" cy="219456"/>
-          </a:xfrm>
-          <a:prstGeom prst="roundRect">
-            <a:avLst>
-              <a:gd name="adj" fmla="val 8000"/>
-            </a:avLst>
-          </a:prstGeom>
-          <a:solidFill>
-            <a:srgbClr val="EEF0FF"/>
-          </a:solidFill>
-          <a:ln>
-            <a:noFill/>
-          </a:ln>
-          <a:effectLst/>
-        </p:spPr>
-        <p:style>
-          <a:lnRef idx="1">
-            <a:schemeClr val="accent1"/>
-          </a:lnRef>
-          <a:fillRef idx="3">
-            <a:schemeClr val="accent1"/>
-          </a:fillRef>
-          <a:effectRef idx="2">
-            <a:schemeClr val="accent1"/>
-          </a:effectRef>
-          <a:fontRef idx="minor">
-            <a:schemeClr val="lt1"/>
-          </a:fontRef>
-        </p:style>
-        <p:txBody>
-          <a:bodyPr rtlCol="0" anchor="ctr"/>
-          <a:lstStyle/>
-          <a:p>
-            <a:pPr algn="ctr"/>
-          </a:p>
-        </p:txBody>
-      </p:sp>
-      <p:sp>
-        <p:nvSpPr>
-          <p:cNvPr id="11" name="TextBox 10"/>
-          <p:cNvSpPr txBox="1"/>
-          <p:nvPr/>
-        </p:nvSpPr>
-        <p:spPr>
-          <a:xfrm>
-            <a:off x="868680" y="1536192"/>
-            <a:ext cx="1463040" cy="219456"/>
-          </a:xfrm>
-          <a:prstGeom prst="rect">
-            <a:avLst/>
-          </a:prstGeom>
-          <a:noFill/>
-        </p:spPr>
-        <p:txBody>
-          <a:bodyPr wrap="square" anchor="t" lIns="0" rIns="0" tIns="0" bIns="0">
-            <a:spAutoFit/>
-          </a:bodyPr>
-          <a:lstStyle/>
-          <a:p>
-            <a:pPr algn="ctr">
-              <a:lnSpc>
-                <a:spcPct val="108000"/>
-              </a:lnSpc>
-              <a:spcAft>
-                <a:spcPts val="300"/>
-              </a:spcAft>
-            </a:pPr>
-            <a:r>
-              <a:rPr sz="900" b="1" i="0">
-                <a:solidFill>
-                  <a:srgbClr val="3854CC"/>
-                </a:solidFill>
-                <a:latin typeface="Montserrat"/>
-              </a:rPr>
-              <a:t>ENUNCIADO CENTRAL</a:t>
-            </a:r>
-          </a:p>
-        </p:txBody>
-      </p:sp>
-      <p:sp>
-        <p:nvSpPr>
-          <p:cNvPr id="12" name="TextBox 11"/>
-          <p:cNvSpPr txBox="1"/>
-          <p:nvPr/>
-        </p:nvSpPr>
-        <p:spPr>
-          <a:xfrm>
-            <a:off x="868680" y="1810512"/>
-            <a:ext cx="6492240" cy="868680"/>
-          </a:xfrm>
-          <a:prstGeom prst="rect">
-            <a:avLst/>
-          </a:prstGeom>
-          <a:noFill/>
-        </p:spPr>
-        <p:txBody>
-          <a:bodyPr wrap="square" anchor="t" lIns="0" rIns="0" tIns="0" bIns="0">
-            <a:spAutoFit/>
-          </a:bodyPr>
-          <a:lstStyle/>
-          <a:p>
-            <a:pPr algn="l">
-              <a:lnSpc>
-                <a:spcPct val="110000"/>
-              </a:lnSpc>
-              <a:spcAft>
-                <a:spcPts val="300"/>
-              </a:spcAft>
-            </a:pPr>
-            <a:r>
-              <a:rPr sz="1550" b="1" i="0">
-                <a:solidFill>
-                  <a:srgbClr val="3854CC"/>
-                </a:solidFill>
-                <a:latin typeface="Montserrat"/>
-              </a:rPr>
-              <a:t>Sobre la pared, la palpación busca cuatro cosas: trofismo, tono, puntos dolorosos y crepitación gaseosa.</a:t>
-            </a:r>
-          </a:p>
-        </p:txBody>
-      </p:sp>
-      <p:sp>
-        <p:nvSpPr>
-          <p:cNvPr id="13" name="Rounded Rectangle 12"/>
-          <p:cNvSpPr/>
-          <p:nvPr/>
-        </p:nvSpPr>
-        <p:spPr>
-          <a:xfrm>
-            <a:off x="594360" y="2880360"/>
-            <a:ext cx="6949440" cy="777240"/>
-          </a:xfrm>
-          <a:prstGeom prst="roundRect">
-            <a:avLst>
-              <a:gd name="adj" fmla="val 4000"/>
-            </a:avLst>
-          </a:prstGeom>
-          <a:solidFill>
-            <a:srgbClr val="EEF0FF"/>
-          </a:solidFill>
-          <a:ln w="5080">
-            <a:solidFill>
-              <a:srgbClr val="D9DDF2"/>
-            </a:solidFill>
-          </a:ln>
-          <a:effectLst/>
-        </p:spPr>
-        <p:style>
-          <a:lnRef idx="1">
-            <a:schemeClr val="accent1"/>
-          </a:lnRef>
-          <a:fillRef idx="3">
-            <a:schemeClr val="accent1"/>
-          </a:fillRef>
-          <a:effectRef idx="2">
-            <a:schemeClr val="accent1"/>
-          </a:effectRef>
-          <a:fontRef idx="minor">
-            <a:schemeClr val="lt1"/>
-          </a:fontRef>
-        </p:style>
-        <p:txBody>
-          <a:bodyPr rtlCol="0" anchor="ctr"/>
-          <a:lstStyle/>
-          <a:p>
-            <a:pPr algn="ctr"/>
-          </a:p>
-        </p:txBody>
-      </p:sp>
-      <p:sp>
-        <p:nvSpPr>
-          <p:cNvPr id="14" name="TextBox 13"/>
-          <p:cNvSpPr txBox="1"/>
-          <p:nvPr/>
-        </p:nvSpPr>
-        <p:spPr>
-          <a:xfrm>
-            <a:off x="777240" y="2990088"/>
-            <a:ext cx="6583679" cy="594360"/>
-          </a:xfrm>
-          <a:prstGeom prst="rect">
-            <a:avLst/>
-          </a:prstGeom>
-          <a:noFill/>
-        </p:spPr>
-        <p:txBody>
-          <a:bodyPr wrap="square" anchor="t" lIns="0" rIns="0" tIns="0" bIns="0">
-            <a:spAutoFit/>
-          </a:bodyPr>
-          <a:lstStyle/>
-          <a:p>
-            <a:pPr algn="l">
-              <a:lnSpc>
-                <a:spcPct val="115000"/>
-              </a:lnSpc>
-              <a:spcAft>
-                <a:spcPts val="300"/>
-              </a:spcAft>
-            </a:pPr>
-            <a:r>
-              <a:rPr sz="1200" b="0" i="0">
-                <a:solidFill>
-                  <a:srgbClr val="2B2C4A"/>
-                </a:solidFill>
-                <a:latin typeface="Montserrat"/>
-              </a:rPr>
-              <a:t>El trofismo se explora pinzando piel y tejido subcutáneo entre pulgar e índice: la atrofia localizada traduce un reflejo visceral.</a:t>
-            </a:r>
-          </a:p>
-        </p:txBody>
-      </p:sp>
-      <p:sp>
-        <p:nvSpPr>
-          <p:cNvPr id="15" name="Rounded Rectangle 14"/>
-          <p:cNvSpPr/>
-          <p:nvPr/>
-        </p:nvSpPr>
-        <p:spPr>
-          <a:xfrm>
-            <a:off x="594360" y="3794760"/>
-            <a:ext cx="3374136" cy="2240279"/>
-          </a:xfrm>
-          <a:prstGeom prst="roundRect">
-            <a:avLst>
-              <a:gd name="adj" fmla="val 4000"/>
-            </a:avLst>
-          </a:prstGeom>
-          <a:solidFill>
-            <a:srgbClr val="FFFFFF"/>
-          </a:solidFill>
-          <a:ln w="7620">
-            <a:solidFill>
-              <a:srgbClr val="D9DDF2"/>
-            </a:solidFill>
-          </a:ln>
-          <a:effectLst/>
-        </p:spPr>
-        <p:style>
-          <a:lnRef idx="1">
-            <a:schemeClr val="accent1"/>
-          </a:lnRef>
-          <a:fillRef idx="3">
-            <a:schemeClr val="accent1"/>
-          </a:fillRef>
-          <a:effectRef idx="2">
-            <a:schemeClr val="accent1"/>
-          </a:effectRef>
-          <a:fontRef idx="minor">
-            <a:schemeClr val="lt1"/>
-          </a:fontRef>
-        </p:style>
-        <p:txBody>
-          <a:bodyPr rtlCol="0" anchor="ctr"/>
-          <a:lstStyle/>
-          <a:p>
-            <a:pPr algn="ctr"/>
-          </a:p>
-        </p:txBody>
-      </p:sp>
-      <p:sp>
-        <p:nvSpPr>
-          <p:cNvPr id="16" name="Rectangle 15"/>
-          <p:cNvSpPr/>
-          <p:nvPr/>
-        </p:nvSpPr>
-        <p:spPr>
-          <a:xfrm>
-            <a:off x="594360" y="3794760"/>
-            <a:ext cx="3374136" cy="45720"/>
-          </a:xfrm>
-          <a:prstGeom prst="rect">
-            <a:avLst/>
-          </a:prstGeom>
-          <a:solidFill>
-            <a:srgbClr val="D92A2B"/>
-          </a:solidFill>
-          <a:ln>
-            <a:noFill/>
-          </a:ln>
-          <a:effectLst/>
-        </p:spPr>
-        <p:style>
-          <a:lnRef idx="1">
-            <a:schemeClr val="accent1"/>
-          </a:lnRef>
-          <a:fillRef idx="3">
-            <a:schemeClr val="accent1"/>
-          </a:fillRef>
-          <a:effectRef idx="2">
-            <a:schemeClr val="accent1"/>
-          </a:effectRef>
-          <a:fontRef idx="minor">
-            <a:schemeClr val="lt1"/>
-          </a:fontRef>
-        </p:style>
-        <p:txBody>
-          <a:bodyPr rtlCol="0" anchor="ctr"/>
-          <a:lstStyle/>
-          <a:p>
-            <a:pPr algn="ctr"/>
-          </a:p>
-        </p:txBody>
-      </p:sp>
-      <p:sp>
-        <p:nvSpPr>
-          <p:cNvPr id="17" name="TextBox 16"/>
-          <p:cNvSpPr txBox="1"/>
-          <p:nvPr/>
-        </p:nvSpPr>
-        <p:spPr>
-          <a:xfrm>
-            <a:off x="777240" y="3959352"/>
-            <a:ext cx="3008376" cy="1965959"/>
-          </a:xfrm>
-          <a:prstGeom prst="rect">
-            <a:avLst/>
-          </a:prstGeom>
-          <a:noFill/>
-        </p:spPr>
-        <p:txBody>
-          <a:bodyPr wrap="square" anchor="t" lIns="0" rIns="0" tIns="0" bIns="0">
-            <a:spAutoFit/>
-          </a:bodyPr>
-          <a:lstStyle/>
-          <a:p>
-            <a:pPr algn="l">
-              <a:lnSpc>
-                <a:spcPct val="108000"/>
-              </a:lnSpc>
-              <a:spcBef>
-                <a:spcPts val="0"/>
-              </a:spcBef>
-              <a:spcAft>
-                <a:spcPts val="400"/>
-              </a:spcAft>
-            </a:pPr>
-            <a:r>
-              <a:rPr sz="1250" b="1" i="0">
-                <a:solidFill>
-                  <a:srgbClr val="3854CC"/>
-                </a:solidFill>
-                <a:latin typeface="Montserrat"/>
-              </a:rPr>
-              <a:t>Tono</a:t>
-            </a:r>
-          </a:p>
-          <a:p>
-            <a:pPr algn="l">
-              <a:lnSpc>
-                <a:spcPct val="110000"/>
-              </a:lnSpc>
-              <a:spcBef>
-                <a:spcPts val="0"/>
-              </a:spcBef>
-              <a:spcAft>
-                <a:spcPts val="300"/>
-              </a:spcAft>
-            </a:pPr>
-            <a:r>
-              <a:rPr sz="1100" b="0" i="0">
-                <a:solidFill>
-                  <a:srgbClr val="2B2C4A"/>
-                </a:solidFill>
-                <a:latin typeface="Montserrat"/>
-              </a:rPr>
-              <a:t>Compresión con la punta del índice: resistencia, contractura o espasmo.</a:t>
-            </a:r>
-          </a:p>
-        </p:txBody>
-      </p:sp>
-      <p:sp>
-        <p:nvSpPr>
-          <p:cNvPr id="18" name="Rounded Rectangle 17"/>
-          <p:cNvSpPr/>
-          <p:nvPr/>
-        </p:nvSpPr>
-        <p:spPr>
-          <a:xfrm>
-            <a:off x="4169664" y="3794760"/>
-            <a:ext cx="3374136" cy="2240279"/>
-          </a:xfrm>
-          <a:prstGeom prst="roundRect">
-            <a:avLst>
-              <a:gd name="adj" fmla="val 4000"/>
-            </a:avLst>
-          </a:prstGeom>
-          <a:solidFill>
-            <a:srgbClr val="FFFFFF"/>
-          </a:solidFill>
-          <a:ln w="7620">
-            <a:solidFill>
-              <a:srgbClr val="D9DDF2"/>
-            </a:solidFill>
-          </a:ln>
-          <a:effectLst/>
-        </p:spPr>
-        <p:style>
-          <a:lnRef idx="1">
-            <a:schemeClr val="accent1"/>
-          </a:lnRef>
-          <a:fillRef idx="3">
-            <a:schemeClr val="accent1"/>
-          </a:fillRef>
-          <a:effectRef idx="2">
-            <a:schemeClr val="accent1"/>
-          </a:effectRef>
-          <a:fontRef idx="minor">
-            <a:schemeClr val="lt1"/>
-          </a:fontRef>
-        </p:style>
-        <p:txBody>
-          <a:bodyPr rtlCol="0" anchor="ctr"/>
-          <a:lstStyle/>
-          <a:p>
-            <a:pPr algn="ctr"/>
-          </a:p>
-        </p:txBody>
-      </p:sp>
-      <p:sp>
-        <p:nvSpPr>
-          <p:cNvPr id="19" name="Rectangle 18"/>
-          <p:cNvSpPr/>
-          <p:nvPr/>
-        </p:nvSpPr>
-        <p:spPr>
-          <a:xfrm>
-            <a:off x="4169664" y="3794760"/>
-            <a:ext cx="3374136" cy="45720"/>
-          </a:xfrm>
-          <a:prstGeom prst="rect">
-            <a:avLst/>
-          </a:prstGeom>
-          <a:solidFill>
-            <a:srgbClr val="D92A2B"/>
-          </a:solidFill>
-          <a:ln>
-            <a:noFill/>
-          </a:ln>
-          <a:effectLst/>
-        </p:spPr>
-        <p:style>
-          <a:lnRef idx="1">
-            <a:schemeClr val="accent1"/>
-          </a:lnRef>
-          <a:fillRef idx="3">
-            <a:schemeClr val="accent1"/>
-          </a:fillRef>
-          <a:effectRef idx="2">
-            <a:schemeClr val="accent1"/>
-          </a:effectRef>
-          <a:fontRef idx="minor">
-            <a:schemeClr val="lt1"/>
-          </a:fontRef>
-        </p:style>
-        <p:txBody>
-          <a:bodyPr rtlCol="0" anchor="ctr"/>
-          <a:lstStyle/>
-          <a:p>
-            <a:pPr algn="ctr"/>
-          </a:p>
-        </p:txBody>
-      </p:sp>
-      <p:sp>
-        <p:nvSpPr>
-          <p:cNvPr id="20" name="TextBox 19"/>
-          <p:cNvSpPr txBox="1"/>
-          <p:nvPr/>
-        </p:nvSpPr>
-        <p:spPr>
-          <a:xfrm>
-            <a:off x="4352544" y="3959352"/>
-            <a:ext cx="3008376" cy="1965959"/>
-          </a:xfrm>
-          <a:prstGeom prst="rect">
-            <a:avLst/>
-          </a:prstGeom>
-          <a:noFill/>
-        </p:spPr>
-        <p:txBody>
-          <a:bodyPr wrap="square" anchor="t" lIns="0" rIns="0" tIns="0" bIns="0">
-            <a:spAutoFit/>
-          </a:bodyPr>
-          <a:lstStyle/>
-          <a:p>
-            <a:pPr algn="l">
-              <a:lnSpc>
-                <a:spcPct val="108000"/>
-              </a:lnSpc>
-              <a:spcBef>
-                <a:spcPts val="0"/>
-              </a:spcBef>
-              <a:spcAft>
-                <a:spcPts val="400"/>
-              </a:spcAft>
-            </a:pPr>
-            <a:r>
-              <a:rPr sz="1250" b="1" i="0">
-                <a:solidFill>
-                  <a:srgbClr val="3854CC"/>
-                </a:solidFill>
-                <a:latin typeface="Montserrat"/>
-              </a:rPr>
-              <a:t>Crepitación</a:t>
-            </a:r>
-          </a:p>
-          <a:p>
-            <a:pPr algn="l">
-              <a:lnSpc>
-                <a:spcPct val="110000"/>
-              </a:lnSpc>
-              <a:spcBef>
-                <a:spcPts val="0"/>
-              </a:spcBef>
-              <a:spcAft>
-                <a:spcPts val="300"/>
-              </a:spcAft>
-            </a:pPr>
-            <a:r>
-              <a:rPr sz="1100" b="0" i="0">
-                <a:solidFill>
-                  <a:srgbClr val="2B2C4A"/>
-                </a:solidFill>
-                <a:latin typeface="Montserrat"/>
-              </a:rPr>
-              <a:t>Enfisema subcutáneo: gas en el tejido, palpable como roce.</a:t>
-            </a:r>
-          </a:p>
-        </p:txBody>
-      </p:sp>
-      <p:sp>
-        <p:nvSpPr>
-          <p:cNvPr id="21" name="Rounded Rectangle 20"/>
-          <p:cNvSpPr/>
-          <p:nvPr/>
-        </p:nvSpPr>
-        <p:spPr>
-          <a:xfrm>
-            <a:off x="7690104" y="1823781"/>
-            <a:ext cx="3913632" cy="3759076"/>
+            <a:off x="557784" y="1701426"/>
+            <a:ext cx="11045952" cy="3775186"/>
           </a:xfrm>
           <a:prstGeom prst="roundRect">
             <a:avLst>
@@ -7826,7 +7196,7 @@
       </p:sp>
       <p:pic>
         <p:nvPicPr>
-          <p:cNvPr id="22" name="Picture 21" descr="fig_3_9.png"/>
+          <p:cNvPr id="9" name="Picture 8" descr="fig_3_9_3_10_3_11.png"/>
           <p:cNvPicPr>
             <a:picLocks noChangeAspect="1"/>
           </p:cNvPicPr>
@@ -7840,8 +7210,8 @@
         </p:blipFill>
         <p:spPr>
           <a:xfrm>
-            <a:off x="7726679" y="1860357"/>
-            <a:ext cx="3840480" cy="3685924"/>
+            <a:off x="594360" y="1738002"/>
+            <a:ext cx="10972800" cy="3702034"/>
           </a:xfrm>
           <a:prstGeom prst="rect">
             <a:avLst/>
@@ -7850,13 +7220,13 @@
       </p:pic>
       <p:sp>
         <p:nvSpPr>
-          <p:cNvPr id="23" name="TextBox 22"/>
+          <p:cNvPr id="10" name="TextBox 9"/>
           <p:cNvSpPr txBox="1"/>
           <p:nvPr/>
         </p:nvSpPr>
         <p:spPr>
           <a:xfrm>
-            <a:off x="594360" y="6053328"/>
+            <a:off x="594360" y="5760720"/>
             <a:ext cx="10972800" cy="256032"/>
           </a:xfrm>
           <a:prstGeom prst="rect">
@@ -7879,13 +7249,55 @@
               </a:spcAft>
             </a:pPr>
             <a:r>
+              <a:rPr sz="1050" b="0" i="1">
+                <a:solidFill>
+                  <a:srgbClr val="2B2C4A"/>
+                </a:solidFill>
+                <a:latin typeface="Montserrat"/>
+              </a:rPr>
+              <a:t>Izquierda: deslizamiento palmar. Centro: pinzamiento del trofismo. Derecha: presión del índice sobre el tono.</a:t>
+            </a:r>
+          </a:p>
+        </p:txBody>
+      </p:sp>
+      <p:sp>
+        <p:nvSpPr>
+          <p:cNvPr id="11" name="TextBox 10"/>
+          <p:cNvSpPr txBox="1"/>
+          <p:nvPr/>
+        </p:nvSpPr>
+        <p:spPr>
+          <a:xfrm>
+            <a:off x="594360" y="6053328"/>
+            <a:ext cx="10972800" cy="256032"/>
+          </a:xfrm>
+          <a:prstGeom prst="rect">
+            <a:avLst/>
+          </a:prstGeom>
+          <a:noFill/>
+        </p:spPr>
+        <p:txBody>
+          <a:bodyPr wrap="square" anchor="t" lIns="0" rIns="0" tIns="0" bIns="0">
+            <a:spAutoFit/>
+          </a:bodyPr>
+          <a:lstStyle/>
+          <a:p>
+            <a:pPr algn="l">
+              <a:lnSpc>
+                <a:spcPct val="108000"/>
+              </a:lnSpc>
+              <a:spcAft>
+                <a:spcPts val="300"/>
+              </a:spcAft>
+            </a:pPr>
+            <a:r>
               <a:rPr sz="900" b="0" i="1">
                 <a:solidFill>
                   <a:srgbClr val="606383"/>
                 </a:solidFill>
                 <a:latin typeface="Montserrat"/>
               </a:rPr>
-              <a:t>Fuente / Crédito: Semiotecnia del tórax, cap. 3, fig. 3-9 (PDF adjunto)</a:t>
+              <a:t>Fuente / Crédito: Semiotecnia del tórax, cap. 3, figs. 3-9, 3-10 y 3-11 (PDF adjunto)</a:t>
             </a:r>
           </a:p>
         </p:txBody>
@@ -11084,7 +10496,7 @@
                 </a:solidFill>
                 <a:latin typeface="Montserrat"/>
               </a:rPr>
-              <a:t>Roce táctil áspero por pleuras despulidas; se percibe en ambas fases respiratorias, con franco predominio inspiratorio.</a:t>
+              <a:t>Roce táctil áspero por pleuras despulidas; se percibe en ambas fases respiratorias, con franco predominio inspiratorio y sin relación con la tos.</a:t>
             </a:r>
           </a:p>
         </p:txBody>
@@ -11243,7 +10655,7 @@
                 </a:solidFill>
                 <a:latin typeface="Montserrat"/>
               </a:rPr>
-              <a:t>Una sola mano, lado a lado y a la misma altura: la asimetría es el hallazgo, no el valor absoluto.</a:t>
+              <a:t>Una sola mano, lado a lado y a la misma altura, de arriba abajo: la asimetría es el hallazgo, nunca el valor absoluto de un hemitórax aislado.</a:t>
             </a:r>
           </a:p>
         </p:txBody>
@@ -20051,7 +19463,7 @@
                 </a:solidFill>
                 <a:latin typeface="Montserrat"/>
               </a:rPr>
-              <a:t>Posición, conformación parietal, deformidades y dinámica ventilatoria; los signos extratorácicos cierran el tiempo.</a:t>
+              <a:t>Posición, conformación parietal, deformidades y dinámica ventilatoria. Los signos extratorácicos —cianosis, tiraje, acropaquia— cierran el tiempo.</a:t>
             </a:r>
           </a:p>
         </p:txBody>
@@ -20210,7 +19622,7 @@
                 </a:solidFill>
                 <a:latin typeface="Montserrat"/>
               </a:rPr>
-              <a:t>Seis maniobras descendentes: pared, cadenas ganglionares, resistencia, expansión y frémito táctil.</a:t>
+              <a:t>Seis maniobras descendentes: pared, cadenas ganglionares, resistencia, expansión torácica y frémito táctil, siempre en comparación transversal.</a:t>
             </a:r>
           </a:p>
         </p:txBody>
@@ -20369,7 +19781,7 @@
                 </a:solidFill>
                 <a:latin typeface="Montserrat"/>
               </a:rPr>
-              <a:t>Mapa de timbres y límites primero; después ruidos, soplos, adventicios, voz y tos.</a:t>
+              <a:t>Primero el mapa de timbres y límites; después ruidos respiratorios, soplos, adventicios, voz y tos, en secuencia simétrica y descendente.</a:t>
             </a:r>
           </a:p>
         </p:txBody>

</xml_diff>

<commit_message>
Deck: tarjetas de key_point a la medida del texto
m_definition calculaba la altura de las tarjetas como el resto de la banda, así
que un enunciado corto dejaba cajas de 4 in con dos líneas. Ahora la altura sale
de est_height (+10%), con mínimo de 1.75 in y el bloque centrado.

Incluye el PDF de vista previa regenerado y la nota en el README del deck.

Co-authored-by: arena-agent <297053741+arena-agent@users.noreply.github.com>
</commit_message>
<xml_diff>
--- a/decks/semiotecnia-torax/semiotecnia_del_torax.pptx
+++ b/decks/semiotecnia-torax/semiotecnia_del_torax.pptx
@@ -4014,8 +4014,8 @@
         </p:nvSpPr>
         <p:spPr>
           <a:xfrm>
-            <a:off x="594360" y="2880360"/>
-            <a:ext cx="5385816" cy="3154679"/>
+            <a:off x="594360" y="3657600"/>
+            <a:ext cx="5385816" cy="1600200"/>
           </a:xfrm>
           <a:prstGeom prst="roundRect">
             <a:avLst>
@@ -4062,7 +4062,7 @@
         </p:nvSpPr>
         <p:spPr>
           <a:xfrm>
-            <a:off x="594360" y="2880360"/>
+            <a:off x="594360" y="3657600"/>
             <a:ext cx="5385816" cy="45720"/>
           </a:xfrm>
           <a:prstGeom prst="rect">
@@ -4106,8 +4106,8 @@
         </p:nvSpPr>
         <p:spPr>
           <a:xfrm>
-            <a:off x="777240" y="3044952"/>
-            <a:ext cx="5020055" cy="2880360"/>
+            <a:off x="777240" y="3822191"/>
+            <a:ext cx="5020055" cy="1325880"/>
           </a:xfrm>
           <a:prstGeom prst="rect">
             <a:avLst/>
@@ -4173,8 +4173,8 @@
         </p:nvSpPr>
         <p:spPr>
           <a:xfrm>
-            <a:off x="6181344" y="2880360"/>
-            <a:ext cx="5385816" cy="3154679"/>
+            <a:off x="6181344" y="3657600"/>
+            <a:ext cx="5385816" cy="1600200"/>
           </a:xfrm>
           <a:prstGeom prst="roundRect">
             <a:avLst>
@@ -4221,7 +4221,7 @@
         </p:nvSpPr>
         <p:spPr>
           <a:xfrm>
-            <a:off x="6181344" y="2880360"/>
+            <a:off x="6181344" y="3657600"/>
             <a:ext cx="5385816" cy="45720"/>
           </a:xfrm>
           <a:prstGeom prst="rect">
@@ -4265,8 +4265,8 @@
         </p:nvSpPr>
         <p:spPr>
           <a:xfrm>
-            <a:off x="6364224" y="3044952"/>
-            <a:ext cx="5020055" cy="2880360"/>
+            <a:off x="6364224" y="3822191"/>
+            <a:ext cx="5020055" cy="1325880"/>
           </a:xfrm>
           <a:prstGeom prst="rect">
             <a:avLst/>
@@ -4828,8 +4828,8 @@
         </p:nvSpPr>
         <p:spPr>
           <a:xfrm>
-            <a:off x="594360" y="2880360"/>
-            <a:ext cx="3523488" cy="3154679"/>
+            <a:off x="594360" y="3657600"/>
+            <a:ext cx="3523488" cy="1600200"/>
           </a:xfrm>
           <a:prstGeom prst="roundRect">
             <a:avLst>
@@ -4876,7 +4876,7 @@
         </p:nvSpPr>
         <p:spPr>
           <a:xfrm>
-            <a:off x="594360" y="2880360"/>
+            <a:off x="594360" y="3657600"/>
             <a:ext cx="3523488" cy="45720"/>
           </a:xfrm>
           <a:prstGeom prst="rect">
@@ -4920,8 +4920,8 @@
         </p:nvSpPr>
         <p:spPr>
           <a:xfrm>
-            <a:off x="777240" y="3044952"/>
-            <a:ext cx="3157728" cy="2880360"/>
+            <a:off x="777240" y="3822191"/>
+            <a:ext cx="3157728" cy="1325880"/>
           </a:xfrm>
           <a:prstGeom prst="rect">
             <a:avLst/>
@@ -4987,8 +4987,8 @@
         </p:nvSpPr>
         <p:spPr>
           <a:xfrm>
-            <a:off x="4319016" y="2880360"/>
-            <a:ext cx="3523488" cy="3154679"/>
+            <a:off x="4319016" y="3657600"/>
+            <a:ext cx="3523488" cy="1600200"/>
           </a:xfrm>
           <a:prstGeom prst="roundRect">
             <a:avLst>
@@ -5035,7 +5035,7 @@
         </p:nvSpPr>
         <p:spPr>
           <a:xfrm>
-            <a:off x="4319016" y="2880360"/>
+            <a:off x="4319016" y="3657600"/>
             <a:ext cx="3523488" cy="45720"/>
           </a:xfrm>
           <a:prstGeom prst="rect">
@@ -5079,8 +5079,8 @@
         </p:nvSpPr>
         <p:spPr>
           <a:xfrm>
-            <a:off x="4501896" y="3044952"/>
-            <a:ext cx="3157728" cy="2880360"/>
+            <a:off x="4501896" y="3822191"/>
+            <a:ext cx="3157728" cy="1325880"/>
           </a:xfrm>
           <a:prstGeom prst="rect">
             <a:avLst/>
@@ -5146,8 +5146,8 @@
         </p:nvSpPr>
         <p:spPr>
           <a:xfrm>
-            <a:off x="8043672" y="2880360"/>
-            <a:ext cx="3523488" cy="3154679"/>
+            <a:off x="8043672" y="3657600"/>
+            <a:ext cx="3523488" cy="1600200"/>
           </a:xfrm>
           <a:prstGeom prst="roundRect">
             <a:avLst>
@@ -5194,7 +5194,7 @@
         </p:nvSpPr>
         <p:spPr>
           <a:xfrm>
-            <a:off x="8043672" y="2880360"/>
+            <a:off x="8043672" y="3657600"/>
             <a:ext cx="3523488" cy="45720"/>
           </a:xfrm>
           <a:prstGeom prst="rect">
@@ -5238,8 +5238,8 @@
         </p:nvSpPr>
         <p:spPr>
           <a:xfrm>
-            <a:off x="8226551" y="3044952"/>
-            <a:ext cx="3157728" cy="2880360"/>
+            <a:off x="8226551" y="3822191"/>
+            <a:ext cx="3157728" cy="1325880"/>
           </a:xfrm>
           <a:prstGeom prst="rect">
             <a:avLst/>
@@ -10350,8 +10350,8 @@
         </p:nvSpPr>
         <p:spPr>
           <a:xfrm>
-            <a:off x="594360" y="3794760"/>
-            <a:ext cx="5385816" cy="2240279"/>
+            <a:off x="594360" y="4114800"/>
+            <a:ext cx="5385816" cy="1600200"/>
           </a:xfrm>
           <a:prstGeom prst="roundRect">
             <a:avLst>
@@ -10398,7 +10398,7 @@
         </p:nvSpPr>
         <p:spPr>
           <a:xfrm>
-            <a:off x="594360" y="3794760"/>
+            <a:off x="594360" y="4114800"/>
             <a:ext cx="5385816" cy="45720"/>
           </a:xfrm>
           <a:prstGeom prst="rect">
@@ -10442,8 +10442,8 @@
         </p:nvSpPr>
         <p:spPr>
           <a:xfrm>
-            <a:off x="777240" y="3959352"/>
-            <a:ext cx="5020055" cy="1965959"/>
+            <a:off x="777240" y="4279392"/>
+            <a:ext cx="5020055" cy="1325880"/>
           </a:xfrm>
           <a:prstGeom prst="rect">
             <a:avLst/>
@@ -10509,8 +10509,8 @@
         </p:nvSpPr>
         <p:spPr>
           <a:xfrm>
-            <a:off x="6181344" y="3794760"/>
-            <a:ext cx="5385816" cy="2240279"/>
+            <a:off x="6181344" y="4114800"/>
+            <a:ext cx="5385816" cy="1600200"/>
           </a:xfrm>
           <a:prstGeom prst="roundRect">
             <a:avLst>
@@ -10557,7 +10557,7 @@
         </p:nvSpPr>
         <p:spPr>
           <a:xfrm>
-            <a:off x="6181344" y="3794760"/>
+            <a:off x="6181344" y="4114800"/>
             <a:ext cx="5385816" cy="45720"/>
           </a:xfrm>
           <a:prstGeom prst="rect">
@@ -10601,8 +10601,8 @@
         </p:nvSpPr>
         <p:spPr>
           <a:xfrm>
-            <a:off x="6364224" y="3959352"/>
-            <a:ext cx="5020055" cy="1965959"/>
+            <a:off x="6364224" y="4279392"/>
+            <a:ext cx="5020055" cy="1325880"/>
           </a:xfrm>
           <a:prstGeom prst="rect">
             <a:avLst/>
@@ -19317,8 +19317,8 @@
         </p:nvSpPr>
         <p:spPr>
           <a:xfrm>
-            <a:off x="594360" y="2880360"/>
-            <a:ext cx="3523488" cy="3154679"/>
+            <a:off x="594360" y="3591242"/>
+            <a:ext cx="3523488" cy="1732915"/>
           </a:xfrm>
           <a:prstGeom prst="roundRect">
             <a:avLst>
@@ -19365,7 +19365,7 @@
         </p:nvSpPr>
         <p:spPr>
           <a:xfrm>
-            <a:off x="594360" y="2880360"/>
+            <a:off x="594360" y="3591242"/>
             <a:ext cx="3523488" cy="45720"/>
           </a:xfrm>
           <a:prstGeom prst="rect">
@@ -19409,8 +19409,8 @@
         </p:nvSpPr>
         <p:spPr>
           <a:xfrm>
-            <a:off x="777240" y="3044952"/>
-            <a:ext cx="3157728" cy="2880360"/>
+            <a:off x="777240" y="3755834"/>
+            <a:ext cx="3157728" cy="1458595"/>
           </a:xfrm>
           <a:prstGeom prst="rect">
             <a:avLst/>
@@ -19476,8 +19476,8 @@
         </p:nvSpPr>
         <p:spPr>
           <a:xfrm>
-            <a:off x="4319016" y="2880360"/>
-            <a:ext cx="3523488" cy="3154679"/>
+            <a:off x="4319016" y="3591242"/>
+            <a:ext cx="3523488" cy="1732915"/>
           </a:xfrm>
           <a:prstGeom prst="roundRect">
             <a:avLst>
@@ -19524,7 +19524,7 @@
         </p:nvSpPr>
         <p:spPr>
           <a:xfrm>
-            <a:off x="4319016" y="2880360"/>
+            <a:off x="4319016" y="3591242"/>
             <a:ext cx="3523488" cy="45720"/>
           </a:xfrm>
           <a:prstGeom prst="rect">
@@ -19568,8 +19568,8 @@
         </p:nvSpPr>
         <p:spPr>
           <a:xfrm>
-            <a:off x="4501896" y="3044952"/>
-            <a:ext cx="3157728" cy="2880360"/>
+            <a:off x="4501896" y="3755834"/>
+            <a:ext cx="3157728" cy="1458595"/>
           </a:xfrm>
           <a:prstGeom prst="rect">
             <a:avLst/>
@@ -19635,8 +19635,8 @@
         </p:nvSpPr>
         <p:spPr>
           <a:xfrm>
-            <a:off x="8043672" y="2880360"/>
-            <a:ext cx="3523488" cy="3154679"/>
+            <a:off x="8043672" y="3591242"/>
+            <a:ext cx="3523488" cy="1732915"/>
           </a:xfrm>
           <a:prstGeom prst="roundRect">
             <a:avLst>
@@ -19683,7 +19683,7 @@
         </p:nvSpPr>
         <p:spPr>
           <a:xfrm>
-            <a:off x="8043672" y="2880360"/>
+            <a:off x="8043672" y="3591242"/>
             <a:ext cx="3523488" cy="45720"/>
           </a:xfrm>
           <a:prstGeom prst="rect">
@@ -19727,8 +19727,8 @@
         </p:nvSpPr>
         <p:spPr>
           <a:xfrm>
-            <a:off x="8226551" y="3044952"/>
-            <a:ext cx="3157728" cy="2880360"/>
+            <a:off x="8226551" y="3755834"/>
+            <a:ext cx="3157728" cy="1458595"/>
           </a:xfrm>
           <a:prstGeom prst="rect">
             <a:avLst/>

</xml_diff>